<commit_message>
feat(docs): atualiza todo o conteudo da apostila, cheatsheets PDF e slides para o estado da arte de 2026
</commit_message>
<xml_diff>
--- a/slides/apresentacao.pptx
+++ b/slides/apresentacao.pptx
@@ -14,7 +14,6 @@
     <p:sldId id="262" r:id="rId13"/>
     <p:sldId id="263" r:id="rId14"/>
     <p:sldId id="264" r:id="rId15"/>
-    <p:sldId id="265" r:id="rId16"/>
   </p:sldIdLst>
   <p:sldSz cx="12191695" cy="6858000" type="screen4x3"/>
   <p:notesSz cx="6858000" cy="9144000"/>
@@ -3169,7 +3168,6 @@
                 <a:solidFill>
                   <a:srgbClr val="F8FAFC"/>
                 </a:solidFill>
-                <a:latin typeface="Arial"/>
               </a:defRPr>
             </a:pPr>
             <a:r>
@@ -3182,11 +3180,10 @@
                 <a:solidFill>
                   <a:srgbClr val="38BDF8"/>
                 </a:solidFill>
-                <a:latin typeface="Arial"/>
-              </a:defRPr>
-            </a:pPr>
-            <a:r>
-              <a:t>SECOMP 2026 — Construindo Aplicações Inteligentes de Alta Performance</a:t>
+              </a:defRPr>
+            </a:pPr>
+            <a:r>
+              <a:t>SECOMP 2026 — Estado da Arte em LLMs, Agentes e RAG Avançado</a:t>
             </a:r>
           </a:p>
         </p:txBody>
@@ -3263,7 +3260,6 @@
                 <a:solidFill>
                   <a:srgbClr val="38BDF8"/>
                 </a:solidFill>
-                <a:latin typeface="Arial"/>
               </a:defRPr>
             </a:pPr>
             <a:r>
@@ -3277,7 +3273,6 @@
                 <a:solidFill>
                   <a:srgbClr val="94A3B8"/>
                 </a:solidFill>
-                <a:latin typeface="Arial"/>
               </a:defRPr>
             </a:pPr>
             <a:r>
@@ -3358,7 +3353,6 @@
                 <a:solidFill>
                   <a:srgbClr val="38BDF8"/>
                 </a:solidFill>
-                <a:latin typeface="Arial"/>
               </a:defRPr>
             </a:pPr>
             <a:r>
@@ -3372,11 +3366,10 @@
                 <a:solidFill>
                   <a:srgbClr val="94A3B8"/>
                 </a:solidFill>
-                <a:latin typeface="Arial"/>
-              </a:defRPr>
-            </a:pPr>
-            <a:r>
-              <a:t>LLMs, Prompt Engineering, MCP, Agentes, RAG e Segurança</a:t>
+              </a:defRPr>
+            </a:pPr>
+            <a:r>
+              <a:t>LLMs 2026, Prompting de Elite, MCP, Agentes, RAG Híbrido e Segurança</a:t>
             </a:r>
           </a:p>
         </p:txBody>
@@ -3453,11 +3446,10 @@
                 <a:solidFill>
                   <a:srgbClr val="38BDF8"/>
                 </a:solidFill>
-                <a:latin typeface="Arial"/>
-              </a:defRPr>
-            </a:pPr>
-            <a:r>
-              <a:t>💻 Projeto Final</a:t>
+              </a:defRPr>
+            </a:pPr>
+            <a:r>
+              <a:t>💻 Projeto Integrador</a:t>
             </a:r>
           </a:p>
           <a:p>
@@ -3467,408 +3459,10 @@
                 <a:solidFill>
                   <a:srgbClr val="94A3B8"/>
                 </a:solidFill>
-                <a:latin typeface="Arial"/>
-              </a:defRPr>
-            </a:pPr>
-            <a:r>
-              <a:t>Career-AI: Assistente de Carreira com IA</a:t>
-            </a:r>
-          </a:p>
-        </p:txBody>
-      </p:sp>
-    </p:spTree>
-  </p:cSld>
-  <p:clrMapOvr>
-    <a:masterClrMapping/>
-  </p:clrMapOvr>
-</p:sld>
-</file>
-
-<file path=ppt/slides/slide10.xml><?xml version="1.0" encoding="utf-8"?>
-<p:sld xmlns:a="http://schemas.openxmlformats.org/drawingml/2006/main" xmlns:p="http://schemas.openxmlformats.org/presentationml/2006/main" xmlns:r="http://schemas.openxmlformats.org/officeDocument/2006/relationships">
-  <p:cSld>
-    <p:spTree>
-      <p:nvGrpSpPr>
-        <p:cNvPr id="1" name=""/>
-        <p:cNvGrpSpPr/>
-        <p:nvPr/>
-      </p:nvGrpSpPr>
-      <p:grpSpPr/>
-      <p:sp>
-        <p:nvSpPr>
-          <p:cNvPr id="2" name="Rectangle 1"/>
-          <p:cNvSpPr/>
-          <p:nvPr/>
-        </p:nvSpPr>
-        <p:spPr>
-          <a:xfrm>
-            <a:off x="0" y="0"/>
-            <a:ext cx="12191695" cy="6858000"/>
-          </a:xfrm>
-          <a:prstGeom prst="rect">
-            <a:avLst/>
-          </a:prstGeom>
-          <a:solidFill>
-            <a:srgbClr val="0F172A"/>
-          </a:solidFill>
-          <a:ln>
-            <a:solidFill>
-              <a:srgbClr val="0F172A"/>
-            </a:solidFill>
-          </a:ln>
-        </p:spPr>
-        <p:style>
-          <a:lnRef idx="1">
-            <a:schemeClr val="accent1"/>
-          </a:lnRef>
-          <a:fillRef idx="3">
-            <a:schemeClr val="accent1"/>
-          </a:fillRef>
-          <a:effectRef idx="2">
-            <a:schemeClr val="accent1"/>
-          </a:effectRef>
-          <a:fontRef idx="minor">
-            <a:schemeClr val="lt1"/>
-          </a:fontRef>
-        </p:style>
-        <p:txBody>
-          <a:bodyPr rtlCol="0" anchor="ctr"/>
-          <a:lstStyle/>
-          <a:p>
-            <a:pPr algn="ctr"/>
-          </a:p>
-        </p:txBody>
-      </p:sp>
-      <p:sp>
-        <p:nvSpPr>
-          <p:cNvPr id="3" name="TextBox 2"/>
-          <p:cNvSpPr txBox="1"/>
-          <p:nvPr/>
-        </p:nvSpPr>
-        <p:spPr>
-          <a:xfrm>
-            <a:off x="731520" y="548640"/>
-            <a:ext cx="10698480" cy="1097280"/>
-          </a:xfrm>
-          <a:prstGeom prst="rect">
-            <a:avLst/>
-          </a:prstGeom>
-          <a:noFill/>
-        </p:spPr>
-        <p:txBody>
-          <a:bodyPr wrap="square">
-            <a:spAutoFit/>
-          </a:bodyPr>
-          <a:lstStyle/>
-          <a:p>
-            <a:pPr>
-              <a:defRPr b="1" sz="3200">
-                <a:solidFill>
-                  <a:srgbClr val="F8FAFC"/>
-                </a:solidFill>
-                <a:latin typeface="Arial"/>
-              </a:defRPr>
-            </a:pPr>
-            <a:r>
-              <a:t>Obrigado! Vamos Praticar!</a:t>
-            </a:r>
-          </a:p>
-          <a:p>
-            <a:pPr>
-              <a:defRPr sz="1600">
-                <a:solidFill>
-                  <a:srgbClr val="38BDF8"/>
-                </a:solidFill>
-                <a:latin typeface="Arial"/>
-              </a:defRPr>
-            </a:pPr>
-            <a:r>
-              <a:t>SECOMP 2026 — Workshop de IA e Agentes Autônomos</a:t>
-            </a:r>
-          </a:p>
-        </p:txBody>
-      </p:sp>
-      <p:sp>
-        <p:nvSpPr>
-          <p:cNvPr id="4" name="Rounded Rectangle 3"/>
-          <p:cNvSpPr/>
-          <p:nvPr/>
-        </p:nvSpPr>
-        <p:spPr>
-          <a:xfrm>
-            <a:off x="731520" y="2011680"/>
-            <a:ext cx="3383280" cy="3931920"/>
-          </a:xfrm>
-          <a:prstGeom prst="roundRect">
-            <a:avLst/>
-          </a:prstGeom>
-          <a:solidFill>
-            <a:srgbClr val="1E293B"/>
-          </a:solidFill>
-          <a:ln w="19050">
-            <a:solidFill>
-              <a:srgbClr val="2563EB"/>
-            </a:solidFill>
-          </a:ln>
-        </p:spPr>
-        <p:style>
-          <a:lnRef idx="1">
-            <a:schemeClr val="accent1"/>
-          </a:lnRef>
-          <a:fillRef idx="3">
-            <a:schemeClr val="accent1"/>
-          </a:fillRef>
-          <a:effectRef idx="2">
-            <a:schemeClr val="accent1"/>
-          </a:effectRef>
-          <a:fontRef idx="minor">
-            <a:schemeClr val="lt1"/>
-          </a:fontRef>
-        </p:style>
-        <p:txBody>
-          <a:bodyPr rtlCol="0" anchor="ctr"/>
-          <a:lstStyle/>
-          <a:p>
-            <a:pPr algn="ctr"/>
-          </a:p>
-        </p:txBody>
-      </p:sp>
-      <p:sp>
-        <p:nvSpPr>
-          <p:cNvPr id="5" name="TextBox 4"/>
-          <p:cNvSpPr txBox="1"/>
-          <p:nvPr/>
-        </p:nvSpPr>
-        <p:spPr>
-          <a:xfrm>
-            <a:off x="914400" y="2286000"/>
-            <a:ext cx="3017520" cy="3383280"/>
-          </a:xfrm>
-          <a:prstGeom prst="rect">
-            <a:avLst/>
-          </a:prstGeom>
-          <a:noFill/>
-        </p:spPr>
-        <p:txBody>
-          <a:bodyPr wrap="square">
-            <a:spAutoFit/>
-          </a:bodyPr>
-          <a:lstStyle/>
-          <a:p>
-            <a:pPr>
-              <a:defRPr b="1" sz="1800">
-                <a:solidFill>
-                  <a:srgbClr val="38BDF8"/>
-                </a:solidFill>
-                <a:latin typeface="Arial"/>
-              </a:defRPr>
-            </a:pPr>
-            <a:r>
-              <a:t>🔗 Repositório Oficial</a:t>
-            </a:r>
-          </a:p>
-          <a:p>
-            <a:br/>
-            <a:pPr>
-              <a:defRPr sz="1400">
-                <a:solidFill>
-                  <a:srgbClr val="94A3B8"/>
-                </a:solidFill>
-                <a:latin typeface="Arial"/>
-              </a:defRPr>
-            </a:pPr>
-            <a:r>
-              <a:t>github.com/EmmanuelNunes/SECOMP---IA</a:t>
-            </a:r>
-          </a:p>
-        </p:txBody>
-      </p:sp>
-      <p:sp>
-        <p:nvSpPr>
-          <p:cNvPr id="6" name="Rounded Rectangle 5"/>
-          <p:cNvSpPr/>
-          <p:nvPr/>
-        </p:nvSpPr>
-        <p:spPr>
-          <a:xfrm>
-            <a:off x="4389120" y="2011680"/>
-            <a:ext cx="3383280" cy="3931920"/>
-          </a:xfrm>
-          <a:prstGeom prst="roundRect">
-            <a:avLst/>
-          </a:prstGeom>
-          <a:solidFill>
-            <a:srgbClr val="1E293B"/>
-          </a:solidFill>
-          <a:ln w="19050">
-            <a:solidFill>
-              <a:srgbClr val="2563EB"/>
-            </a:solidFill>
-          </a:ln>
-        </p:spPr>
-        <p:style>
-          <a:lnRef idx="1">
-            <a:schemeClr val="accent1"/>
-          </a:lnRef>
-          <a:fillRef idx="3">
-            <a:schemeClr val="accent1"/>
-          </a:fillRef>
-          <a:effectRef idx="2">
-            <a:schemeClr val="accent1"/>
-          </a:effectRef>
-          <a:fontRef idx="minor">
-            <a:schemeClr val="lt1"/>
-          </a:fontRef>
-        </p:style>
-        <p:txBody>
-          <a:bodyPr rtlCol="0" anchor="ctr"/>
-          <a:lstStyle/>
-          <a:p>
-            <a:pPr algn="ctr"/>
-          </a:p>
-        </p:txBody>
-      </p:sp>
-      <p:sp>
-        <p:nvSpPr>
-          <p:cNvPr id="7" name="TextBox 6"/>
-          <p:cNvSpPr txBox="1"/>
-          <p:nvPr/>
-        </p:nvSpPr>
-        <p:spPr>
-          <a:xfrm>
-            <a:off x="4572000" y="2286000"/>
-            <a:ext cx="3017520" cy="3383280"/>
-          </a:xfrm>
-          <a:prstGeom prst="rect">
-            <a:avLst/>
-          </a:prstGeom>
-          <a:noFill/>
-        </p:spPr>
-        <p:txBody>
-          <a:bodyPr wrap="square">
-            <a:spAutoFit/>
-          </a:bodyPr>
-          <a:lstStyle/>
-          <a:p>
-            <a:pPr>
-              <a:defRPr b="1" sz="1800">
-                <a:solidFill>
-                  <a:srgbClr val="38BDF8"/>
-                </a:solidFill>
-                <a:latin typeface="Arial"/>
-              </a:defRPr>
-            </a:pPr>
-            <a:r>
-              <a:t>📂 Laboratórios</a:t>
-            </a:r>
-          </a:p>
-          <a:p>
-            <a:br/>
-            <a:pPr>
-              <a:defRPr sz="1400">
-                <a:solidFill>
-                  <a:srgbClr val="94A3B8"/>
-                </a:solidFill>
-                <a:latin typeface="Arial"/>
-              </a:defRPr>
-            </a:pPr>
-            <a:r>
-              <a:t>Acesse a pasta /laboratorios para os notebooks práticos.</a:t>
-            </a:r>
-          </a:p>
-        </p:txBody>
-      </p:sp>
-      <p:sp>
-        <p:nvSpPr>
-          <p:cNvPr id="8" name="Rounded Rectangle 7"/>
-          <p:cNvSpPr/>
-          <p:nvPr/>
-        </p:nvSpPr>
-        <p:spPr>
-          <a:xfrm>
-            <a:off x="8046720" y="2011680"/>
-            <a:ext cx="3383280" cy="3931920"/>
-          </a:xfrm>
-          <a:prstGeom prst="roundRect">
-            <a:avLst/>
-          </a:prstGeom>
-          <a:solidFill>
-            <a:srgbClr val="1E293B"/>
-          </a:solidFill>
-          <a:ln w="19050">
-            <a:solidFill>
-              <a:srgbClr val="2563EB"/>
-            </a:solidFill>
-          </a:ln>
-        </p:spPr>
-        <p:style>
-          <a:lnRef idx="1">
-            <a:schemeClr val="accent1"/>
-          </a:lnRef>
-          <a:fillRef idx="3">
-            <a:schemeClr val="accent1"/>
-          </a:fillRef>
-          <a:effectRef idx="2">
-            <a:schemeClr val="accent1"/>
-          </a:effectRef>
-          <a:fontRef idx="minor">
-            <a:schemeClr val="lt1"/>
-          </a:fontRef>
-        </p:style>
-        <p:txBody>
-          <a:bodyPr rtlCol="0" anchor="ctr"/>
-          <a:lstStyle/>
-          <a:p>
-            <a:pPr algn="ctr"/>
-          </a:p>
-        </p:txBody>
-      </p:sp>
-      <p:sp>
-        <p:nvSpPr>
-          <p:cNvPr id="9" name="TextBox 8"/>
-          <p:cNvSpPr txBox="1"/>
-          <p:nvPr/>
-        </p:nvSpPr>
-        <p:spPr>
-          <a:xfrm>
-            <a:off x="8229600" y="2286000"/>
-            <a:ext cx="3017520" cy="3383280"/>
-          </a:xfrm>
-          <a:prstGeom prst="rect">
-            <a:avLst/>
-          </a:prstGeom>
-          <a:noFill/>
-        </p:spPr>
-        <p:txBody>
-          <a:bodyPr wrap="square">
-            <a:spAutoFit/>
-          </a:bodyPr>
-          <a:lstStyle/>
-          <a:p>
-            <a:pPr>
-              <a:defRPr b="1" sz="1800">
-                <a:solidFill>
-                  <a:srgbClr val="38BDF8"/>
-                </a:solidFill>
-                <a:latin typeface="Arial"/>
-              </a:defRPr>
-            </a:pPr>
-            <a:r>
-              <a:t>👨‍💻 Bons Estudos!</a:t>
-            </a:r>
-          </a:p>
-          <a:p>
-            <a:br/>
-            <a:pPr>
-              <a:defRPr sz="1400">
-                <a:solidFill>
-                  <a:srgbClr val="94A3B8"/>
-                </a:solidFill>
-                <a:latin typeface="Arial"/>
-              </a:defRPr>
-            </a:pPr>
-            <a:r>
-              <a:t>Emmanuel Nunes — SECOMP 2026</a:t>
+              </a:defRPr>
+            </a:pPr>
+            <a:r>
+              <a:t>Career-AI: Assistente de Carreira Inteligente End-to-End</a:t>
             </a:r>
           </a:p>
         </p:txBody>
@@ -3963,11 +3557,10 @@
                 <a:solidFill>
                   <a:srgbClr val="F8FAFC"/>
                 </a:solidFill>
-                <a:latin typeface="Arial"/>
-              </a:defRPr>
-            </a:pPr>
-            <a:r>
-              <a:t>Visão Geral do Workshop</a:t>
+              </a:defRPr>
+            </a:pPr>
+            <a:r>
+              <a:t>Módulo 01: LLMs &amp; Modelos de Raciocínio</a:t>
             </a:r>
           </a:p>
           <a:p>
@@ -3976,11 +3569,10 @@
                 <a:solidFill>
                   <a:srgbClr val="38BDF8"/>
                 </a:solidFill>
-                <a:latin typeface="Arial"/>
-              </a:defRPr>
-            </a:pPr>
-            <a:r>
-              <a:t>Jornada Prática do Conceito à Produção</a:t>
+              </a:defRPr>
+            </a:pPr>
+            <a:r>
+              <a:t>Test-Time Compute, MoE e Multimodalidade Nativa</a:t>
             </a:r>
           </a:p>
         </p:txBody>
@@ -4057,11 +3649,10 @@
                 <a:solidFill>
                   <a:srgbClr val="38BDF8"/>
                 </a:solidFill>
-                <a:latin typeface="Arial"/>
-              </a:defRPr>
-            </a:pPr>
-            <a:r>
-              <a:t>01. Fundamentos &amp; Prompts</a:t>
+              </a:defRPr>
+            </a:pPr>
+            <a:r>
+              <a:t>🧠 Reasoning Models</a:t>
             </a:r>
           </a:p>
           <a:p>
@@ -4071,11 +3662,10 @@
                 <a:solidFill>
                   <a:srgbClr val="94A3B8"/>
                 </a:solidFill>
-                <a:latin typeface="Arial"/>
-              </a:defRPr>
-            </a:pPr>
-            <a:r>
-              <a:t>Entenda a arquitetura de LLMs e domine os 4 pilares de um prompt de alta qualidade.</a:t>
+              </a:defRPr>
+            </a:pPr>
+            <a:r>
+              <a:t>Cadeias de pensamento internas (Chain-of-Thought) para solução de problemas complexos.</a:t>
             </a:r>
           </a:p>
         </p:txBody>
@@ -4152,11 +3742,10 @@
                 <a:solidFill>
                   <a:srgbClr val="38BDF8"/>
                 </a:solidFill>
-                <a:latin typeface="Arial"/>
-              </a:defRPr>
-            </a:pPr>
-            <a:r>
-              <a:t>02. Integração via MCP</a:t>
+              </a:defRPr>
+            </a:pPr>
+            <a:r>
+              <a:t>🌐 Google Workspace + Gemini</a:t>
             </a:r>
           </a:p>
           <a:p>
@@ -4166,11 +3755,10 @@
                 <a:solidFill>
                   <a:srgbClr val="94A3B8"/>
                 </a:solidFill>
-                <a:latin typeface="Arial"/>
-              </a:defRPr>
-            </a:pPr>
-            <a:r>
-              <a:t>Padronize a comunicação da IA com APIs, bancos de dados e ferramentas locais.</a:t>
+              </a:defRPr>
+            </a:pPr>
+            <a:r>
+              <a:t>Deep Research, Canvas, NotebookLM Audio Overviews e integração privada.</a:t>
             </a:r>
           </a:p>
         </p:txBody>
@@ -4247,11 +3835,10 @@
                 <a:solidFill>
                   <a:srgbClr val="38BDF8"/>
                 </a:solidFill>
-                <a:latin typeface="Arial"/>
-              </a:defRPr>
-            </a:pPr>
-            <a:r>
-              <a:t>03. Agentes &amp; RAG</a:t>
+              </a:defRPr>
+            </a:pPr>
+            <a:r>
+              <a:t>📚 Long Context (10M+)</a:t>
             </a:r>
           </a:p>
           <a:p>
@@ -4261,11 +3848,10 @@
                 <a:solidFill>
                   <a:srgbClr val="94A3B8"/>
                 </a:solidFill>
-                <a:latin typeface="Arial"/>
-              </a:defRPr>
-            </a:pPr>
-            <a:r>
-              <a:t>Crie agentes com capacidade de raciocínio, ferramentas e memória vetorial persistente.</a:t>
+              </a:defRPr>
+            </a:pPr>
+            <a:r>
+              <a:t>Processamento de repositórios completos e grandes bases documentais.</a:t>
             </a:r>
           </a:p>
         </p:txBody>
@@ -4360,11 +3946,10 @@
                 <a:solidFill>
                   <a:srgbClr val="F8FAFC"/>
                 </a:solidFill>
-                <a:latin typeface="Arial"/>
-              </a:defRPr>
-            </a:pPr>
-            <a:r>
-              <a:t>Módulo 01: Introdução aos LLMs</a:t>
+              </a:defRPr>
+            </a:pPr>
+            <a:r>
+              <a:t>Módulo 02: Engenharia de Prompts de Elite</a:t>
             </a:r>
           </a:p>
           <a:p>
@@ -4373,11 +3958,10 @@
                 <a:solidFill>
                   <a:srgbClr val="38BDF8"/>
                 </a:solidFill>
-                <a:latin typeface="Arial"/>
-              </a:defRPr>
-            </a:pPr>
-            <a:r>
-              <a:t>Arquitetura e Fundamentos dos Modelos de Linguagem</a:t>
+              </a:defRPr>
+            </a:pPr>
+            <a:r>
+              <a:t>Técnicas Avançadas e Outputs Estruturados</a:t>
             </a:r>
           </a:p>
         </p:txBody>
@@ -4454,11 +4038,10 @@
                 <a:solidFill>
                   <a:srgbClr val="38BDF8"/>
                 </a:solidFill>
-                <a:latin typeface="Arial"/>
-              </a:defRPr>
-            </a:pPr>
-            <a:r>
-              <a:t>🧠 Modelos Autoregressivos</a:t>
+              </a:defRPr>
+            </a:pPr>
+            <a:r>
+              <a:t>🎯 5 Pilares de Prompts</a:t>
             </a:r>
           </a:p>
           <a:p>
@@ -4468,11 +4051,10 @@
                 <a:solidFill>
                   <a:srgbClr val="94A3B8"/>
                 </a:solidFill>
-                <a:latin typeface="Arial"/>
-              </a:defRPr>
-            </a:pPr>
-            <a:r>
-              <a:t>Como os LLMs preveem o próximo token com base em contexto e atenção (Transformers).</a:t>
+              </a:defRPr>
+            </a:pPr>
+            <a:r>
+              <a:t>Role, Task, Context, Constraints e Output Format delimitados.</a:t>
             </a:r>
           </a:p>
         </p:txBody>
@@ -4549,11 +4131,10 @@
                 <a:solidFill>
                   <a:srgbClr val="38BDF8"/>
                 </a:solidFill>
-                <a:latin typeface="Arial"/>
-              </a:defRPr>
-            </a:pPr>
-            <a:r>
-              <a:t>🌐 Google Workspace &amp; Gemini</a:t>
+              </a:defRPr>
+            </a:pPr>
+            <a:r>
+              <a:t>XML Delimiters</a:t>
             </a:r>
           </a:p>
           <a:p>
@@ -4563,11 +4144,10 @@
                 <a:solidFill>
                   <a:srgbClr val="94A3B8"/>
                 </a:solidFill>
-                <a:latin typeface="Arial"/>
-              </a:defRPr>
-            </a:pPr>
-            <a:r>
-              <a:t>Uso de IA corporativa com privacidade, Deep Research, Canvas e NotebookLM.</a:t>
+              </a:defRPr>
+            </a:pPr>
+            <a:r>
+              <a:t>Prevenção de confusão de contexto utilizando tags XML estruturadas.</a:t>
             </a:r>
           </a:p>
         </p:txBody>
@@ -4644,11 +4224,10 @@
                 <a:solidFill>
                   <a:srgbClr val="38BDF8"/>
                 </a:solidFill>
-                <a:latin typeface="Arial"/>
-              </a:defRPr>
-            </a:pPr>
-            <a:r>
-              <a:t>🔑 Caso de Uso Real</a:t>
+              </a:defRPr>
+            </a:pPr>
+            <a:r>
+              <a:t>📊 Structured Outputs</a:t>
             </a:r>
           </a:p>
           <a:p>
@@ -4658,11 +4237,10 @@
                 <a:solidFill>
                   <a:srgbClr val="94A3B8"/>
                 </a:solidFill>
-                <a:latin typeface="Arial"/>
-              </a:defRPr>
-            </a:pPr>
-            <a:r>
-              <a:t>Aplicações de alto impacto no cotidiano de desenvolvimento e gestão de produtos.</a:t>
+              </a:defRPr>
+            </a:pPr>
+            <a:r>
+              <a:t>Garantia matemática de conformidade de saída com Schemas JSON / Pydantic.</a:t>
             </a:r>
           </a:p>
         </p:txBody>
@@ -4757,11 +4335,10 @@
                 <a:solidFill>
                   <a:srgbClr val="F8FAFC"/>
                 </a:solidFill>
-                <a:latin typeface="Arial"/>
-              </a:defRPr>
-            </a:pPr>
-            <a:r>
-              <a:t>Módulo 02: Engenharia de Prompts</a:t>
+              </a:defRPr>
+            </a:pPr>
+            <a:r>
+              <a:t>Módulo 03: Model Context Protocol (MCP)</a:t>
             </a:r>
           </a:p>
           <a:p>
@@ -4770,11 +4347,10 @@
                 <a:solidFill>
                   <a:srgbClr val="38BDF8"/>
                 </a:solidFill>
-                <a:latin typeface="Arial"/>
-              </a:defRPr>
-            </a:pPr>
-            <a:r>
-              <a:t>Direcionando LLMs com Precisão e Estrutura</a:t>
+              </a:defRPr>
+            </a:pPr>
+            <a:r>
+              <a:t>A Especificação Aberta de Conexão de IA</a:t>
             </a:r>
           </a:p>
         </p:txBody>
@@ -4851,11 +4427,10 @@
                 <a:solidFill>
                   <a:srgbClr val="38BDF8"/>
                 </a:solidFill>
-                <a:latin typeface="Arial"/>
-              </a:defRPr>
-            </a:pPr>
-            <a:r>
-              <a:t>🎯 Os 4 Pilares</a:t>
+              </a:defRPr>
+            </a:pPr>
+            <a:r>
+              <a:t>🛠️ Tools</a:t>
             </a:r>
           </a:p>
           <a:p>
@@ -4865,11 +4440,10 @@
                 <a:solidFill>
                   <a:srgbClr val="94A3B8"/>
                 </a:solidFill>
-                <a:latin typeface="Arial"/>
-              </a:defRPr>
-            </a:pPr>
-            <a:r>
-              <a:t>Persona, Task (Tarefa), Context (Contexto) e Format (Formato de Saída).</a:t>
+              </a:defRPr>
+            </a:pPr>
+            <a:r>
+              <a:t>Funções executáveis com parâmetros validados via JSON Schema.</a:t>
             </a:r>
           </a:p>
         </p:txBody>
@@ -4946,11 +4520,10 @@
                 <a:solidFill>
                   <a:srgbClr val="38BDF8"/>
                 </a:solidFill>
-                <a:latin typeface="Arial"/>
-              </a:defRPr>
-            </a:pPr>
-            <a:r>
-              <a:t>🔄 Iteração Conversacional</a:t>
+              </a:defRPr>
+            </a:pPr>
+            <a:r>
+              <a:t>📁 Resources</a:t>
             </a:r>
           </a:p>
           <a:p>
@@ -4960,11 +4533,10 @@
                 <a:solidFill>
                   <a:srgbClr val="94A3B8"/>
                 </a:solidFill>
-                <a:latin typeface="Arial"/>
-              </a:defRPr>
-            </a:pPr>
-            <a:r>
-              <a:t>Refinamento contínuo de instruções em vez de reescrita total dos prompts.</a:t>
+              </a:defRPr>
+            </a:pPr>
+            <a:r>
+              <a:t>Fontes de leitura estáticas e dinâmicas expostas via URIs personalizadas.</a:t>
             </a:r>
           </a:p>
         </p:txBody>
@@ -5041,11 +4613,10 @@
                 <a:solidFill>
                   <a:srgbClr val="38BDF8"/>
                 </a:solidFill>
-                <a:latin typeface="Arial"/>
-              </a:defRPr>
-            </a:pPr>
-            <a:r>
-              <a:t>📌 Grounding</a:t>
+              </a:defRPr>
+            </a:pPr>
+            <a:r>
+              <a:t>⚡ Stdio &amp; SSE Transports</a:t>
             </a:r>
           </a:p>
           <a:p>
@@ -5055,11 +4626,10 @@
                 <a:solidFill>
                   <a:srgbClr val="94A3B8"/>
                 </a:solidFill>
-                <a:latin typeface="Arial"/>
-              </a:defRPr>
-            </a:pPr>
-            <a:r>
-              <a:t>Vinculação de contexto estrito com marcações (@documento) para evitar alucinações.</a:t>
+              </a:defRPr>
+            </a:pPr>
+            <a:r>
+              <a:t>Comunicação padronizada em JSON-RPC 2.0 local e em nuvem.</a:t>
             </a:r>
           </a:p>
         </p:txBody>
@@ -5154,11 +4724,10 @@
                 <a:solidFill>
                   <a:srgbClr val="F8FAFC"/>
                 </a:solidFill>
-                <a:latin typeface="Arial"/>
-              </a:defRPr>
-            </a:pPr>
-            <a:r>
-              <a:t>Módulo 03: Model Context Protocol (MCP)</a:t>
+              </a:defRPr>
+            </a:pPr>
+            <a:r>
+              <a:t>Módulo 04: Agentes Autônomos</a:t>
             </a:r>
           </a:p>
           <a:p>
@@ -5167,11 +4736,10 @@
                 <a:solidFill>
                   <a:srgbClr val="38BDF8"/>
                 </a:solidFill>
-                <a:latin typeface="Arial"/>
-              </a:defRPr>
-            </a:pPr>
-            <a:r>
-              <a:t>O Padrão Aberto de Conexão para Agentes</a:t>
+              </a:defRPr>
+            </a:pPr>
+            <a:r>
+              <a:t>Loops ReAct e Orquestração Multi-Agente</a:t>
             </a:r>
           </a:p>
         </p:txBody>
@@ -5248,11 +4816,10 @@
                 <a:solidFill>
                   <a:srgbClr val="38BDF8"/>
                 </a:solidFill>
-                <a:latin typeface="Arial"/>
-              </a:defRPr>
-            </a:pPr>
-            <a:r>
-              <a:t>🛠️ Tools (Ferramentas)</a:t>
+              </a:defRPr>
+            </a:pPr>
+            <a:r>
+              <a:t>🔄 Ciclo ReAct</a:t>
             </a:r>
           </a:p>
           <a:p>
@@ -5262,11 +4829,10 @@
                 <a:solidFill>
                   <a:srgbClr val="94A3B8"/>
                 </a:solidFill>
-                <a:latin typeface="Arial"/>
-              </a:defRPr>
-            </a:pPr>
-            <a:r>
-              <a:t>Funções executáveis invocadas pela IA (ex: commits, execução de scripts).</a:t>
+              </a:defRPr>
+            </a:pPr>
+            <a:r>
+              <a:t>Reasoning + Acting em loops de percepção, planejamento e ação.</a:t>
             </a:r>
           </a:p>
         </p:txBody>
@@ -5343,11 +4909,10 @@
                 <a:solidFill>
                   <a:srgbClr val="38BDF8"/>
                 </a:solidFill>
-                <a:latin typeface="Arial"/>
-              </a:defRPr>
-            </a:pPr>
-            <a:r>
-              <a:t>📁 Resources (Recursos)</a:t>
+              </a:defRPr>
+            </a:pPr>
+            <a:r>
+              <a:t>👥 Orquestração Multi-Agente</a:t>
             </a:r>
           </a:p>
           <a:p>
@@ -5357,11 +4922,10 @@
                 <a:solidFill>
                   <a:srgbClr val="94A3B8"/>
                 </a:solidFill>
-                <a:latin typeface="Arial"/>
-              </a:defRPr>
-            </a:pPr>
-            <a:r>
-              <a:t>Fontes de dados estáticas e dinâmicas expostas para leitura estrita do agente.</a:t>
+              </a:defRPr>
+            </a:pPr>
+            <a:r>
+              <a:t>Padrão Supervisor distribuindo sub-tarefas para agentes especialistas.</a:t>
             </a:r>
           </a:p>
         </p:txBody>
@@ -5438,11 +5002,10 @@
                 <a:solidFill>
                   <a:srgbClr val="38BDF8"/>
                 </a:solidFill>
-                <a:latin typeface="Arial"/>
-              </a:defRPr>
-            </a:pPr>
-            <a:r>
-              <a:t>⚡ Prompts &amp; Protocolo</a:t>
+              </a:defRPr>
+            </a:pPr>
+            <a:r>
+              <a:t>👤 Human in the Loop</a:t>
             </a:r>
           </a:p>
           <a:p>
@@ -5452,11 +5015,10 @@
                 <a:solidFill>
                   <a:srgbClr val="94A3B8"/>
                 </a:solidFill>
-                <a:latin typeface="Arial"/>
-              </a:defRPr>
-            </a:pPr>
-            <a:r>
-              <a:t>Comunicação via JSON-RPC unificando clientes e servidores de ferramentas.</a:t>
+              </a:defRPr>
+            </a:pPr>
+            <a:r>
+              <a:t>Aprovação humana mandatória para ações destrutivas ou de risco.</a:t>
             </a:r>
           </a:p>
         </p:txBody>
@@ -5551,11 +5113,10 @@
                 <a:solidFill>
                   <a:srgbClr val="F8FAFC"/>
                 </a:solidFill>
-                <a:latin typeface="Arial"/>
-              </a:defRPr>
-            </a:pPr>
-            <a:r>
-              <a:t>Módulo 04: Agentes Autônomos</a:t>
+              </a:defRPr>
+            </a:pPr>
+            <a:r>
+              <a:t>Módulo 05: RAG Avançado &amp; GraphRAG</a:t>
             </a:r>
           </a:p>
           <a:p>
@@ -5564,11 +5125,10 @@
                 <a:solidFill>
                   <a:srgbClr val="38BDF8"/>
                 </a:solidFill>
-                <a:latin typeface="Arial"/>
-              </a:defRPr>
-            </a:pPr>
-            <a:r>
-              <a:t>Tomada de Decisão, Loops e Ferramentas</a:t>
+              </a:defRPr>
+            </a:pPr>
+            <a:r>
+              <a:t>Busca Híbrida, Reranking e Grafos de Conhecimento</a:t>
             </a:r>
           </a:p>
         </p:txBody>
@@ -5645,11 +5205,10 @@
                 <a:solidFill>
                   <a:srgbClr val="38BDF8"/>
                 </a:solidFill>
-                <a:latin typeface="Arial"/>
-              </a:defRPr>
-            </a:pPr>
-            <a:r>
-              <a:t>🔄 ReAct Loop</a:t>
+              </a:defRPr>
+            </a:pPr>
+            <a:r>
+              <a:t>⚡ Hybrid Search</a:t>
             </a:r>
           </a:p>
           <a:p>
@@ -5659,11 +5218,10 @@
                 <a:solidFill>
                   <a:srgbClr val="94A3B8"/>
                 </a:solidFill>
-                <a:latin typeface="Arial"/>
-              </a:defRPr>
-            </a:pPr>
-            <a:r>
-              <a:t>Ciclo de Raciocínio (Reasoning) e Ação (Acting) para resolver tarefas complexas.</a:t>
+              </a:defRPr>
+            </a:pPr>
+            <a:r>
+              <a:t>Combinação de busca vetorial densa com busca por palavras-chave (BM25) via RRF.</a:t>
             </a:r>
           </a:p>
         </p:txBody>
@@ -5740,11 +5298,10 @@
                 <a:solidFill>
                   <a:srgbClr val="38BDF8"/>
                 </a:solidFill>
-                <a:latin typeface="Arial"/>
-              </a:defRPr>
-            </a:pPr>
-            <a:r>
-              <a:t>🧰 Tool Usage</a:t>
+              </a:defRPr>
+            </a:pPr>
+            <a:r>
+              <a:t>🎯 Cross-Encoder Reranking</a:t>
             </a:r>
           </a:p>
           <a:p>
@@ -5754,11 +5311,10 @@
                 <a:solidFill>
                   <a:srgbClr val="94A3B8"/>
                 </a:solidFill>
-                <a:latin typeface="Arial"/>
-              </a:defRPr>
-            </a:pPr>
-            <a:r>
-              <a:t>Seleção dinâmica de ferramentas com base no plano de ação e parâmetros.</a:t>
+              </a:defRPr>
+            </a:pPr>
+            <a:r>
+              <a:t>Reordenação ultra-precisa dos fragmentos antes de enviar ao LLM.</a:t>
             </a:r>
           </a:p>
         </p:txBody>
@@ -5835,11 +5391,10 @@
                 <a:solidFill>
                   <a:srgbClr val="38BDF8"/>
                 </a:solidFill>
-                <a:latin typeface="Arial"/>
-              </a:defRPr>
-            </a:pPr>
-            <a:r>
-              <a:t>👥 Orquestração Multi-Agente</a:t>
+              </a:defRPr>
+            </a:pPr>
+            <a:r>
+              <a:t>🕸️ GraphRAG</a:t>
             </a:r>
           </a:p>
           <a:p>
@@ -5849,11 +5404,10 @@
                 <a:solidFill>
                   <a:srgbClr val="94A3B8"/>
                 </a:solidFill>
-                <a:latin typeface="Arial"/>
-              </a:defRPr>
-            </a:pPr>
-            <a:r>
-              <a:t>Especialização de papéis (pesquisa, código, revisão) em equipe.</a:t>
+              </a:defRPr>
+            </a:pPr>
+            <a:r>
+              <a:t>Grafos de conhecimento para sintetizar respostas sobre datasets interconectados.</a:t>
             </a:r>
           </a:p>
         </p:txBody>
@@ -5948,11 +5502,10 @@
                 <a:solidFill>
                   <a:srgbClr val="F8FAFC"/>
                 </a:solidFill>
-                <a:latin typeface="Arial"/>
-              </a:defRPr>
-            </a:pPr>
-            <a:r>
-              <a:t>Módulo 05: RAG (Retrieval-Augmented Generation)</a:t>
+              </a:defRPr>
+            </a:pPr>
+            <a:r>
+              <a:t>Módulo 06: Segurança &amp; OWASP Top 10</a:t>
             </a:r>
           </a:p>
           <a:p>
@@ -5961,11 +5514,10 @@
                 <a:solidFill>
                   <a:srgbClr val="38BDF8"/>
                 </a:solidFill>
-                <a:latin typeface="Arial"/>
-              </a:defRPr>
-            </a:pPr>
-            <a:r>
-              <a:t>Memória Semântica e Busca Vetorial</a:t>
+              </a:defRPr>
+            </a:pPr>
+            <a:r>
+              <a:t>Proteção contra Injeção, Vazamentos e Agência Excessiva</a:t>
             </a:r>
           </a:p>
         </p:txBody>
@@ -6042,11 +5594,10 @@
                 <a:solidFill>
                   <a:srgbClr val="38BDF8"/>
                 </a:solidFill>
-                <a:latin typeface="Arial"/>
-              </a:defRPr>
-            </a:pPr>
-            <a:r>
-              <a:t>📄 Chunking &amp; Embedding</a:t>
+              </a:defRPr>
+            </a:pPr>
+            <a:r>
+              <a:t>🛡️ Prompt Injection</a:t>
             </a:r>
           </a:p>
           <a:p>
@@ -6056,11 +5607,10 @@
                 <a:solidFill>
                   <a:srgbClr val="94A3B8"/>
                 </a:solidFill>
-                <a:latin typeface="Arial"/>
-              </a:defRPr>
-            </a:pPr>
-            <a:r>
-              <a:t>Divisão estratégica do texto e vetorização semântica via sentence-transformers.</a:t>
+              </a:defRPr>
+            </a:pPr>
+            <a:r>
+              <a:t>Proteção contra injeções diretas e indiretas em textos recuperados via RAG.</a:t>
             </a:r>
           </a:p>
         </p:txBody>
@@ -6137,11 +5687,10 @@
                 <a:solidFill>
                   <a:srgbClr val="38BDF8"/>
                 </a:solidFill>
-                <a:latin typeface="Arial"/>
-              </a:defRPr>
-            </a:pPr>
-            <a:r>
-              <a:t>🗄️ Vector DB (ChromaDB)</a:t>
+              </a:defRPr>
+            </a:pPr>
+            <a:r>
+              <a:t>🔐 Data Leakage &amp; RBAC</a:t>
             </a:r>
           </a:p>
           <a:p>
@@ -6151,11 +5700,10 @@
                 <a:solidFill>
                   <a:srgbClr val="94A3B8"/>
                 </a:solidFill>
-                <a:latin typeface="Arial"/>
-              </a:defRPr>
-            </a:pPr>
-            <a:r>
-              <a:t>Armazenamento e busca por similaridade de cosseno em tempo real.</a:t>
+              </a:defRPr>
+            </a:pPr>
+            <a:r>
+              <a:t>Controle de acesso granular e anonimização de PII no Vector DB.</a:t>
             </a:r>
           </a:p>
         </p:txBody>
@@ -6232,11 +5780,10 @@
                 <a:solidFill>
                   <a:srgbClr val="38BDF8"/>
                 </a:solidFill>
-                <a:latin typeface="Arial"/>
-              </a:defRPr>
-            </a:pPr>
-            <a:r>
-              <a:t>🎯 Grounded Generation</a:t>
+              </a:defRPr>
+            </a:pPr>
+            <a:r>
+              <a:t>🚨 Guardrails Ativos</a:t>
             </a:r>
           </a:p>
           <a:p>
@@ -6246,11 +5793,10 @@
                 <a:solidFill>
                   <a:srgbClr val="94A3B8"/>
                 </a:solidFill>
-                <a:latin typeface="Arial"/>
-              </a:defRPr>
-            </a:pPr>
-            <a:r>
-              <a:t>Envio dos contextos recuperados para garantir respostas 100% embasadas.</a:t>
+              </a:defRPr>
+            </a:pPr>
+            <a:r>
+              <a:t>Filtros de segurança de entrada e saída operando em milissegundos.</a:t>
             </a:r>
           </a:p>
         </p:txBody>
@@ -6345,11 +5891,10 @@
                 <a:solidFill>
                   <a:srgbClr val="F8FAFC"/>
                 </a:solidFill>
-                <a:latin typeface="Arial"/>
-              </a:defRPr>
-            </a:pPr>
-            <a:r>
-              <a:t>Módulo 06: Segurança em IA</a:t>
+              </a:defRPr>
+            </a:pPr>
+            <a:r>
+              <a:t>Projeto Integrador: Career-AI</a:t>
             </a:r>
           </a:p>
           <a:p>
@@ -6358,11 +5903,10 @@
                 <a:solidFill>
                   <a:srgbClr val="38BDF8"/>
                 </a:solidFill>
-                <a:latin typeface="Arial"/>
-              </a:defRPr>
-            </a:pPr>
-            <a:r>
-              <a:t>Proteção, Guardrails e Conformidade</a:t>
+              </a:defRPr>
+            </a:pPr>
+            <a:r>
+              <a:t>Assistente de Carreira Inteligente de Produção</a:t>
             </a:r>
           </a:p>
         </p:txBody>
@@ -6439,11 +5983,10 @@
                 <a:solidFill>
                   <a:srgbClr val="38BDF8"/>
                 </a:solidFill>
-                <a:latin typeface="Arial"/>
-              </a:defRPr>
-            </a:pPr>
-            <a:r>
-              <a:t>🛡️ Prompt Injection &amp; Jailbreak</a:t>
+              </a:defRPr>
+            </a:pPr>
+            <a:r>
+              <a:t>⚙️ Backend FastAPI</a:t>
             </a:r>
           </a:p>
           <a:p>
@@ -6453,11 +5996,10 @@
                 <a:solidFill>
                   <a:srgbClr val="94A3B8"/>
                 </a:solidFill>
-                <a:latin typeface="Arial"/>
-              </a:defRPr>
-            </a:pPr>
-            <a:r>
-              <a:t>Sanitização de inputs e implementação de guardrails na entrada e saída.</a:t>
+              </a:defRPr>
+            </a:pPr>
+            <a:r>
+              <a:t>Rotas REST, serviços de RAG e integração com agentes LangGraph.</a:t>
             </a:r>
           </a:p>
         </p:txBody>
@@ -6534,11 +6076,10 @@
                 <a:solidFill>
                   <a:srgbClr val="38BDF8"/>
                 </a:solidFill>
-                <a:latin typeface="Arial"/>
-              </a:defRPr>
-            </a:pPr>
-            <a:r>
-              <a:t>🔐 Data Leakage &amp; RBAC</a:t>
+              </a:defRPr>
+            </a:pPr>
+            <a:r>
+              <a:t>💻 Frontend Interativo</a:t>
             </a:r>
           </a:p>
           <a:p>
@@ -6548,11 +6089,10 @@
                 <a:solidFill>
                   <a:srgbClr val="94A3B8"/>
                 </a:solidFill>
-                <a:latin typeface="Arial"/>
-              </a:defRPr>
-            </a:pPr>
-            <a:r>
-              <a:t>Controle de acesso granular às bases RAG e ferramentas do servidor MCP.</a:t>
+              </a:defRPr>
+            </a:pPr>
+            <a:r>
+              <a:t>Interface web moderna com suporte a múltiplos agentes de carreira.</a:t>
             </a:r>
           </a:p>
         </p:txBody>
@@ -6629,11 +6169,10 @@
                 <a:solidFill>
                   <a:srgbClr val="38BDF8"/>
                 </a:solidFill>
-                <a:latin typeface="Arial"/>
-              </a:defRPr>
-            </a:pPr>
-            <a:r>
-              <a:t>👤 Human in the Loop</a:t>
+              </a:defRPr>
+            </a:pPr>
+            <a:r>
+              <a:t>📊 Datasets &amp; Vetores</a:t>
             </a:r>
           </a:p>
           <a:p>
@@ -6643,11 +6182,10 @@
                 <a:solidFill>
                   <a:srgbClr val="94A3B8"/>
                 </a:solidFill>
-                <a:latin typeface="Arial"/>
-              </a:defRPr>
-            </a:pPr>
-            <a:r>
-              <a:t>Aprovações humanas para ações de alto risco (Menor Privilégio).</a:t>
+              </a:defRPr>
+            </a:pPr>
+            <a:r>
+              <a:t>Perguntas de entrevista, tutoriais e vetorização em ChromaDB.</a:t>
             </a:r>
           </a:p>
         </p:txBody>
@@ -6742,11 +6280,10 @@
                 <a:solidFill>
                   <a:srgbClr val="F8FAFC"/>
                 </a:solidFill>
-                <a:latin typeface="Arial"/>
-              </a:defRPr>
-            </a:pPr>
-            <a:r>
-              <a:t>Projeto Final: Career-AI</a:t>
+              </a:defRPr>
+            </a:pPr>
+            <a:r>
+              <a:t>Obrigado! Vamos à Prática!</a:t>
             </a:r>
           </a:p>
           <a:p>
@@ -6755,11 +6292,10 @@
                 <a:solidFill>
                   <a:srgbClr val="38BDF8"/>
                 </a:solidFill>
-                <a:latin typeface="Arial"/>
-              </a:defRPr>
-            </a:pPr>
-            <a:r>
-              <a:t>Assistente de Carreira Inteligente End-to-End</a:t>
+              </a:defRPr>
+            </a:pPr>
+            <a:r>
+              <a:t>SECOMP 2026 — Workshop de IA e Agentes Autônomos</a:t>
             </a:r>
           </a:p>
         </p:txBody>
@@ -6836,11 +6372,10 @@
                 <a:solidFill>
                   <a:srgbClr val="38BDF8"/>
                 </a:solidFill>
-                <a:latin typeface="Arial"/>
-              </a:defRPr>
-            </a:pPr>
-            <a:r>
-              <a:t>⚙️ Backend (Python/FastAPI)</a:t>
+              </a:defRPr>
+            </a:pPr>
+            <a:r>
+              <a:t>🔗 Repositório Oficial</a:t>
             </a:r>
           </a:p>
           <a:p>
@@ -6850,11 +6385,10 @@
                 <a:solidFill>
                   <a:srgbClr val="94A3B8"/>
                 </a:solidFill>
-                <a:latin typeface="Arial"/>
-              </a:defRPr>
-            </a:pPr>
-            <a:r>
-              <a:t>Pipeline RAG, serviços de agentes e rotas da aplicação.</a:t>
+              </a:defRPr>
+            </a:pPr>
+            <a:r>
+              <a:t>github.com/EmmanuelNunes/SECOMP---IA</a:t>
             </a:r>
           </a:p>
         </p:txBody>
@@ -6931,11 +6465,10 @@
                 <a:solidFill>
                   <a:srgbClr val="38BDF8"/>
                 </a:solidFill>
-                <a:latin typeface="Arial"/>
-              </a:defRPr>
-            </a:pPr>
-            <a:r>
-              <a:t>💻 Frontend Interativo</a:t>
+              </a:defRPr>
+            </a:pPr>
+            <a:r>
+              <a:t>📂 Laboratórios</a:t>
             </a:r>
           </a:p>
           <a:p>
@@ -6945,11 +6478,10 @@
                 <a:solidFill>
                   <a:srgbClr val="94A3B8"/>
                 </a:solidFill>
-                <a:latin typeface="Arial"/>
-              </a:defRPr>
-            </a:pPr>
-            <a:r>
-              <a:t>Interface web moderna para interação e feedback do usuário.</a:t>
+              </a:defRPr>
+            </a:pPr>
+            <a:r>
+              <a:t>Execute os notebooks em /laboratorios para fixação.</a:t>
             </a:r>
           </a:p>
         </p:txBody>
@@ -7026,11 +6558,10 @@
                 <a:solidFill>
                   <a:srgbClr val="38BDF8"/>
                 </a:solidFill>
-                <a:latin typeface="Arial"/>
-              </a:defRPr>
-            </a:pPr>
-            <a:r>
-              <a:t>📊 Datasets &amp; Prompts</a:t>
+              </a:defRPr>
+            </a:pPr>
+            <a:r>
+              <a:t>👨‍💻 Bons Estudos!</a:t>
             </a:r>
           </a:p>
           <a:p>
@@ -7040,11 +6571,10 @@
                 <a:solidFill>
                   <a:srgbClr val="94A3B8"/>
                 </a:solidFill>
-                <a:latin typeface="Arial"/>
-              </a:defRPr>
-            </a:pPr>
-            <a:r>
-              <a:t>Perguntas de entrevista, guias de estudo e otimização de currículos.</a:t>
+              </a:defRPr>
+            </a:pPr>
+            <a:r>
+              <a:t>Emmanuel Nunes — SECOMP 2026</a:t>
             </a:r>
           </a:p>
         </p:txBody>

</xml_diff>

<commit_message>
docs & refs: adiciona creditos e referencias academicas do Prof. Sanderson Macedo (arXiv/ResearchGate/GitHub)
</commit_message>
<xml_diff>
--- a/slides/apresentacao.pptx
+++ b/slides/apresentacao.pptx
@@ -3356,7 +3356,7 @@
               </a:defRPr>
             </a:pPr>
             <a:r>
-              <a:t>🚀 Foco Prático</a:t>
+              <a:t>🔬 Fundamentação Científica</a:t>
             </a:r>
           </a:p>
           <a:p>
@@ -3369,7 +3369,7 @@
               </a:defRPr>
             </a:pPr>
             <a:r>
-              <a:t>LLMs 2026, Prompting de Elite, MCP, Agentes, RAG Híbrido e Segurança</a:t>
+              <a:t>Pesquisas &amp; Ferramentas do Prof. Sanderson Macedo (IFG/UFG)</a:t>
             </a:r>
           </a:p>
         </p:txBody>
@@ -4727,7 +4727,7 @@
               </a:defRPr>
             </a:pPr>
             <a:r>
-              <a:t>Módulo 04: Agentes Autônomos</a:t>
+              <a:t>Módulo 04: Agentes &amp; Agent Harnesses</a:t>
             </a:r>
           </a:p>
           <a:p>
@@ -4739,7 +4739,7 @@
               </a:defRPr>
             </a:pPr>
             <a:r>
-              <a:t>Loops ReAct e Orquestração Multi-Agente</a:t>
+              <a:t>Conceitos de Harnessing e Framework Reversa (Macedo, 2026)</a:t>
             </a:r>
           </a:p>
         </p:txBody>
@@ -4819,7 +4819,7 @@
               </a:defRPr>
             </a:pPr>
             <a:r>
-              <a:t>🔄 Ciclo ReAct</a:t>
+              <a:t>🏗️ Agent Harnesses</a:t>
             </a:r>
           </a:p>
           <a:p>
@@ -4832,7 +4832,7 @@
               </a:defRPr>
             </a:pPr>
             <a:r>
-              <a:t>Reasoning + Acting em loops de percepção, planejamento e ação.</a:t>
+              <a:t>Definição de camadas de encapsulamento para agentes de código (arXiv:2606.10106).</a:t>
             </a:r>
           </a:p>
         </p:txBody>
@@ -4912,7 +4912,7 @@
               </a:defRPr>
             </a:pPr>
             <a:r>
-              <a:t>👥 Orquestração Multi-Agente</a:t>
+              <a:t>🔄 Framework Reversa</a:t>
             </a:r>
           </a:p>
           <a:p>
@@ -4925,7 +4925,7 @@
               </a:defRPr>
             </a:pPr>
             <a:r>
-              <a:t>Padrão Supervisor distribuindo sub-tarefas para agentes especialistas.</a:t>
+              <a:t>Engenharia reversa de código legado para especificações executáveis por IA (arXiv:2605.18684).</a:t>
             </a:r>
           </a:p>
         </p:txBody>
@@ -5894,7 +5894,7 @@
               </a:defRPr>
             </a:pPr>
             <a:r>
-              <a:t>Projeto Integrador: Career-AI</a:t>
+              <a:t>Créditos &amp; Referências Acadêmicas</a:t>
             </a:r>
           </a:p>
           <a:p>
@@ -5906,7 +5906,7 @@
               </a:defRPr>
             </a:pPr>
             <a:r>
-              <a:t>Assistente de Carreira Inteligente de Produção</a:t>
+              <a:t>Homenagem e Referências ao Prof. Sanderson Macedo (Prof. Sandeco)</a:t>
             </a:r>
           </a:p>
         </p:txBody>
@@ -5986,7 +5986,7 @@
               </a:defRPr>
             </a:pPr>
             <a:r>
-              <a:t>⚙️ Backend FastAPI</a:t>
+              <a:t>🔬 Pesquisas arXiv (2026)</a:t>
             </a:r>
           </a:p>
           <a:p>
@@ -5999,7 +5999,7 @@
               </a:defRPr>
             </a:pPr>
             <a:r>
-              <a:t>Rotas REST, serviços de RAG e integração com agentes LangGraph.</a:t>
+              <a:t>Agent Harnesses (arXiv:2606.10106), Process Taxonomy (arXiv:2606.04967) e Reversa (arXiv:2605.18684).</a:t>
             </a:r>
           </a:p>
         </p:txBody>
@@ -6079,7 +6079,7 @@
               </a:defRPr>
             </a:pPr>
             <a:r>
-              <a:t>💻 Frontend Interativo</a:t>
+              <a:t>🎥 Canal Sandeco</a:t>
             </a:r>
           </a:p>
           <a:p>
@@ -6092,7 +6092,7 @@
               </a:defRPr>
             </a:pPr>
             <a:r>
-              <a:t>Interface web moderna com suporte a múltiplos agentes de carreira.</a:t>
+              <a:t>Conteúdos didáticos e aulas de referência em IA (youtube.com/canalsandeco).</a:t>
             </a:r>
           </a:p>
         </p:txBody>
@@ -6172,7 +6172,7 @@
               </a:defRPr>
             </a:pPr>
             <a:r>
-              <a:t>📊 Datasets &amp; Vetores</a:t>
+              <a:t>🐙 GitHub @sandeco</a:t>
             </a:r>
           </a:p>
           <a:p>
@@ -6185,7 +6185,7 @@
               </a:defRPr>
             </a:pPr>
             <a:r>
-              <a:t>Perguntas de entrevista, tutoriais e vetorização em ChromaDB.</a:t>
+              <a:t>Framework Reversa, Mira Animator e ecossistema de projetos open-source.</a:t>
             </a:r>
           </a:p>
         </p:txBody>
@@ -6574,7 +6574,7 @@
               </a:defRPr>
             </a:pPr>
             <a:r>
-              <a:t>Emmanuel Nunes — SECOMP 2026</a:t>
+              <a:t>Emmanuel Nunes &amp; Prof. Sanderson Macedo — SECOMP 2026</a:t>
             </a:r>
           </a:p>
         </p:txBody>

</xml_diff>

<commit_message>
docs: atualiza equipe de mantenedores (Emmanuel Nunes, Prof. Dr. Carlos Alex Gulo e Prof. Sanderson Macedo)
</commit_message>
<xml_diff>
--- a/slides/apresentacao.pptx
+++ b/slides/apresentacao.pptx
@@ -3263,7 +3263,7 @@
               </a:defRPr>
             </a:pPr>
             <a:r>
-              <a:t>👨‍🏫 Instrutor</a:t>
+              <a:t>👨‍🏫 Instrutor &amp; Dev</a:t>
             </a:r>
           </a:p>
           <a:p>
@@ -3356,7 +3356,7 @@
               </a:defRPr>
             </a:pPr>
             <a:r>
-              <a:t>🔬 Fundamentação Científica</a:t>
+              <a:t>🎓 Equipe Acadêmica</a:t>
             </a:r>
           </a:p>
           <a:p>
@@ -3369,7 +3369,7 @@
               </a:defRPr>
             </a:pPr>
             <a:r>
-              <a:t>Pesquisas &amp; Ferramentas do Prof. Sanderson Macedo (IFG/UFG)</a:t>
+              <a:t>Prof. Dr. Carlos Alex Sander Juvêncio Gulo (UNEMAT)</a:t>
             </a:r>
           </a:p>
         </p:txBody>
@@ -3449,7 +3449,7 @@
               </a:defRPr>
             </a:pPr>
             <a:r>
-              <a:t>💻 Projeto Integrador</a:t>
+              <a:t>🔬 Referencial Metodológico</a:t>
             </a:r>
           </a:p>
           <a:p>
@@ -3462,7 +3462,7 @@
               </a:defRPr>
             </a:pPr>
             <a:r>
-              <a:t>Career-AI: Assistente de Carreira Inteligente End-to-End</a:t>
+              <a:t>Prof. M.Sc. Sanderson Macedo - Prof. Sandeco (IFG/UFG)</a:t>
             </a:r>
           </a:p>
         </p:txBody>
@@ -5894,7 +5894,7 @@
               </a:defRPr>
             </a:pPr>
             <a:r>
-              <a:t>Créditos &amp; Referências Acadêmicas</a:t>
+              <a:t>Mantenedores &amp; Referencial Metodológico</a:t>
             </a:r>
           </a:p>
           <a:p>
@@ -5906,7 +5906,7 @@
               </a:defRPr>
             </a:pPr>
             <a:r>
-              <a:t>Homenagem e Referências ao Prof. Sanderson Macedo (Prof. Sandeco)</a:t>
+              <a:t>Equipe do Workshop e Referência Científica</a:t>
             </a:r>
           </a:p>
         </p:txBody>
@@ -5986,7 +5986,7 @@
               </a:defRPr>
             </a:pPr>
             <a:r>
-              <a:t>🔬 Pesquisas arXiv (2026)</a:t>
+              <a:t>💻 Emmanuel Nunes</a:t>
             </a:r>
           </a:p>
           <a:p>
@@ -5999,7 +5999,7 @@
               </a:defRPr>
             </a:pPr>
             <a:r>
-              <a:t>Agent Harnesses (arXiv:2606.10106), Process Taxonomy (arXiv:2606.04967) e Reversa (arXiv:2605.18684).</a:t>
+              <a:t>Instrutor e Desenvolvedor da Aplicação e Materiais (GitHub: @EmmanuelNunes).</a:t>
             </a:r>
           </a:p>
         </p:txBody>
@@ -6079,7 +6079,7 @@
               </a:defRPr>
             </a:pPr>
             <a:r>
-              <a:t>🎥 Canal Sandeco</a:t>
+              <a:t>🎓 Prof. Dr. Carlos Alex Gulo</a:t>
             </a:r>
           </a:p>
           <a:p>
@@ -6092,7 +6092,7 @@
               </a:defRPr>
             </a:pPr>
             <a:r>
-              <a:t>Conteúdos didáticos e aulas de referência em IA (youtube.com/canalsandeco).</a:t>
+              <a:t>Professor e Pesquisador (UNEMAT / Grupo PIXEL).</a:t>
             </a:r>
           </a:p>
         </p:txBody>
@@ -6172,7 +6172,7 @@
               </a:defRPr>
             </a:pPr>
             <a:r>
-              <a:t>🐙 GitHub @sandeco</a:t>
+              <a:t>🔬 Prof. Sanderson Macedo</a:t>
             </a:r>
           </a:p>
           <a:p>
@@ -6185,7 +6185,7 @@
               </a:defRPr>
             </a:pPr>
             <a:r>
-              <a:t>Framework Reversa, Mira Animator e ecossistema de projetos open-source.</a:t>
+              <a:t>Prof. Sandeco (IFG/UFG) — Referencial Metodológico &amp; Pesquisador (GitHub: @sandeco).</a:t>
             </a:r>
           </a:p>
         </p:txBody>
@@ -6574,7 +6574,7 @@
               </a:defRPr>
             </a:pPr>
             <a:r>
-              <a:t>Emmanuel Nunes &amp; Prof. Sanderson Macedo — SECOMP 2026</a:t>
+              <a:t>Emmanuel Nunes, Prof. Carlos Alex Gulo &amp; Prof. Sanderson Macedo — SECOMP 2026</a:t>
             </a:r>
           </a:p>
         </p:txBody>

</xml_diff>

<commit_message>
docs: remove Prof. Sanderson Macedo da lista de mantenedores (mantido em Referencial Metodologico e Creditos)
</commit_message>
<xml_diff>
--- a/slides/apresentacao.pptx
+++ b/slides/apresentacao.pptx
@@ -6172,7 +6172,7 @@
               </a:defRPr>
             </a:pPr>
             <a:r>
-              <a:t>🔬 Prof. Sanderson Macedo</a:t>
+              <a:t>🔬 Referência Científica</a:t>
             </a:r>
           </a:p>
           <a:p>
@@ -6185,7 +6185,7 @@
               </a:defRPr>
             </a:pPr>
             <a:r>
-              <a:t>Prof. Sandeco (IFG/UFG) — Referencial Metodológico &amp; Pesquisador (GitHub: @sandeco).</a:t>
+              <a:t>Prof. Sanderson Macedo (IFG/UFG) — Referencial Metodológico &amp; Pesquisador (arXiv/GitHub).</a:t>
             </a:r>
           </a:p>
         </p:txBody>
@@ -6574,7 +6574,7 @@
               </a:defRPr>
             </a:pPr>
             <a:r>
-              <a:t>Emmanuel Nunes, Prof. Carlos Alex Gulo &amp; Prof. Sanderson Macedo — SECOMP 2026</a:t>
+              <a:t>Emmanuel Nunes &amp; Prof. Carlos Alex Gulo — SECOMP 2026</a:t>
             </a:r>
           </a:p>
         </p:txBody>

</xml_diff>